<commit_message>
Update README + slides with ViT 93.81% and RViT 92.31% test acc; add model docs with reviewer Q&A
</commit_message>
<xml_diff>
--- a/PRESENTATION/presentation.pptx
+++ b/PRESENTATION/presentation.pptx
@@ -5921,7 +5921,7 @@
         <p:spPr>
           <a:xfrm>
             <a:off x="7776210" y="1238250"/>
-            <a:ext cx="3840480" cy="1162050"/>
+            <a:ext cx="3840480" cy="2258381"/>
           </a:xfrm>
           <a:prstGeom prst="roundRect">
             <a:avLst/>
@@ -6026,6 +6026,80 @@
             <a:r>
               <a:rPr dirty="0"/>
               <a:t>87.65 M</a:t>
+            </a:r>
+          </a:p>
+        </p:txBody>
+      </p:sp>
+      <p:sp>
+        <p:nvSpPr>
+          <p:cNvPr id="10" name="TextBox 10"/>
+          <p:cNvSpPr txBox="1"/>
+          <p:nvPr/>
+        </p:nvSpPr>
+        <p:spPr>
+          <a:xfrm>
+            <a:off x="8138160" y="2491742"/>
+            <a:ext cx="2926080" cy="320040"/>
+          </a:xfrm>
+          <a:prstGeom prst="rect">
+            <a:avLst/>
+          </a:prstGeom>
+          <a:noFill/>
+        </p:spPr>
+        <p:txBody>
+          <a:bodyPr wrap="square">
+            <a:spAutoFit/>
+          </a:bodyPr>
+          <a:lstStyle/>
+          <a:p>
+            <a:pPr algn="ctr">
+              <a:defRPr sz="1000" b="1">
+                <a:solidFill>
+                  <a:srgbClr val="5A6C7D"/>
+                </a:solidFill>
+                <a:latin typeface="Calibri"/>
+              </a:defRPr>
+            </a:pPr>
+            <a:r>
+              <a:rPr dirty="0"/>
+              <a:t>OUR TEST ACC</a:t>
+            </a:r>
+          </a:p>
+        </p:txBody>
+      </p:sp>
+      <p:sp>
+        <p:nvSpPr>
+          <p:cNvPr id="11" name="TextBox 11"/>
+          <p:cNvSpPr txBox="1"/>
+          <p:nvPr/>
+        </p:nvSpPr>
+        <p:spPr>
+          <a:xfrm>
+            <a:off x="8138160" y="2698910"/>
+            <a:ext cx="2926080" cy="457200"/>
+          </a:xfrm>
+          <a:prstGeom prst="rect">
+            <a:avLst/>
+          </a:prstGeom>
+          <a:noFill/>
+        </p:spPr>
+        <p:txBody>
+          <a:bodyPr wrap="square">
+            <a:spAutoFit/>
+          </a:bodyPr>
+          <a:lstStyle/>
+          <a:p>
+            <a:pPr algn="ctr">
+              <a:defRPr sz="2000" b="1">
+                <a:solidFill>
+                  <a:srgbClr val="0F2A44"/>
+                </a:solidFill>
+                <a:latin typeface="Calibri"/>
+              </a:defRPr>
+            </a:pPr>
+            <a:r>
+              <a:rPr dirty="0"/>
+              <a:t>93.81%</a:t>
             </a:r>
           </a:p>
         </p:txBody>
@@ -10672,7 +10746,7 @@
         <p:spPr>
           <a:xfrm>
             <a:off x="7852410" y="914400"/>
-            <a:ext cx="3840480" cy="1485901"/>
+            <a:ext cx="3840480" cy="2401731"/>
           </a:xfrm>
           <a:prstGeom prst="roundRect">
             <a:avLst/>
@@ -10776,6 +10850,80 @@
             <a:r>
               <a:rPr dirty="0"/>
               <a:t>128.45 M</a:t>
+            </a:r>
+          </a:p>
+        </p:txBody>
+      </p:sp>
+      <p:sp>
+        <p:nvSpPr>
+          <p:cNvPr id="4" name="TextBox 16"/>
+          <p:cNvSpPr txBox="1"/>
+          <p:nvPr/>
+        </p:nvSpPr>
+        <p:spPr>
+          <a:xfrm>
+            <a:off x="8309610" y="2286003"/>
+            <a:ext cx="2926080" cy="320040"/>
+          </a:xfrm>
+          <a:prstGeom prst="rect">
+            <a:avLst/>
+          </a:prstGeom>
+          <a:noFill/>
+        </p:spPr>
+        <p:txBody>
+          <a:bodyPr wrap="square">
+            <a:spAutoFit/>
+          </a:bodyPr>
+          <a:lstStyle/>
+          <a:p>
+            <a:pPr algn="ctr">
+              <a:defRPr sz="1000" b="1">
+                <a:solidFill>
+                  <a:srgbClr val="5A6C7D"/>
+                </a:solidFill>
+                <a:latin typeface="Calibri"/>
+              </a:defRPr>
+            </a:pPr>
+            <a:r>
+              <a:rPr dirty="0"/>
+              <a:t>OUR TEST ACC</a:t>
+            </a:r>
+          </a:p>
+        </p:txBody>
+      </p:sp>
+      <p:sp>
+        <p:nvSpPr>
+          <p:cNvPr id="5" name="TextBox 17"/>
+          <p:cNvSpPr txBox="1"/>
+          <p:nvPr/>
+        </p:nvSpPr>
+        <p:spPr>
+          <a:xfrm>
+            <a:off x="8309610" y="2493171"/>
+            <a:ext cx="2926080" cy="457200"/>
+          </a:xfrm>
+          <a:prstGeom prst="rect">
+            <a:avLst/>
+          </a:prstGeom>
+          <a:noFill/>
+        </p:spPr>
+        <p:txBody>
+          <a:bodyPr wrap="square">
+            <a:spAutoFit/>
+          </a:bodyPr>
+          <a:lstStyle/>
+          <a:p>
+            <a:pPr algn="ctr">
+              <a:defRPr sz="1700" b="1">
+                <a:solidFill>
+                  <a:srgbClr val="0F2A44"/>
+                </a:solidFill>
+                <a:latin typeface="Calibri"/>
+              </a:defRPr>
+            </a:pPr>
+            <a:r>
+              <a:rPr dirty="0"/>
+              <a:t>92.31%</a:t>
             </a:r>
           </a:p>
         </p:txBody>

</xml_diff>